<commit_message>
docs: add team members to the project report and deck
</commit_message>
<xml_diff>
--- a/docs/ShaderMesh-Presentation.pptx
+++ b/docs/ShaderMesh-Presentation.pptx
@@ -5031,13 +5031,13 @@
               </a:spcAft>
             </a:pPr>
             <a:r>
-              <a:rPr sz="1800" b="1">
+              <a:rPr sz="1300" b="1">
                 <a:solidFill>
                   <a:srgbClr val="1A1814"/>
                 </a:solidFill>
                 <a:latin typeface="Segoe UI"/>
               </a:rPr>
-              <a:t>[TEAM MEMBERS]</a:t>
+              <a:t>Rakesh Kumar Rabha (24BCC7002), Nilam Sikdar (24BCC7025), Animesh Mishra (24BCC7016)</a:t>
             </a:r>
           </a:p>
           <a:p>

</xml_diff>